<commit_message>
Hardening: rate limits, redacted logs, data export, image limits, CI, backups, docs
</commit_message>
<xml_diff>
--- a/docs/RailScan_overview.pptx
+++ b/docs/RailScan_overview.pptx
@@ -16,7 +16,7 @@
     <p:sldMasterId id="2147483996" r:id="rId15"/>
   </p:sldMasterIdLst>
   <p:notesMasterIdLst>
-    <p:notesMasterId r:id="rId23"/>
+    <p:notesMasterId r:id="rId25"/>
   </p:notesMasterIdLst>
   <p:sldIdLst>
     <p:sldId id="4568" r:id="rId16"/>
@@ -26,6 +26,8 @@
     <p:sldId id="4572" r:id="rId20"/>
     <p:sldId id="4573" r:id="rId21"/>
     <p:sldId id="4574" r:id="rId22"/>
+    <p:sldId id="4575" r:id="rId23"/>
+    <p:sldId id="4576" r:id="rId24"/>
   </p:sldIdLst>
   <p:sldSz cx="12192000" cy="6858000"/>
   <p:notesSz cx="7004050" cy="9290050"/>
@@ -136,6 +138,8 @@
             <p14:sldId id="4572"/>
             <p14:sldId id="4573"/>
             <p14:sldId id="4574"/>
+            <p14:sldId id="4575"/>
+            <p14:sldId id="4576"/>
           </p14:sldIdLst>
         </p14:section>
       </p14:sectionLst>
@@ -29222,7 +29226,7 @@
                   <a:srgbClr val="404040"/>
                 </a:solidFill>
               </a:rPr>
-              <a:t>   Python – journey planner, station matching, position estimate, accounts with salted password hashes</a:t>
+              <a:t>   Python – journey planner, station matching, position estimate, accounts, rate limits, redacted logs</a:t>
             </a:r>
           </a:p>
         </p:txBody>
@@ -29330,7 +29334,7 @@
                   <a:srgbClr val="404040"/>
                 </a:solidFill>
               </a:rPr>
-              <a:t>   TensorFlow / Keras CNN (MobileNetV2) · EasyOCR on PyTorch · OpenCV for image clean-up</a:t>
+              <a:t>   Keras CNN (MobileNetV2) and EasyOCR, both on PyTorch · OpenCV for image clean-up</a:t>
             </a:r>
           </a:p>
         </p:txBody>
@@ -29546,7 +29550,7 @@
                   <a:srgbClr val="404040"/>
                 </a:solidFill>
               </a:rPr>
-              <a:t>   SQLite (0.92 million rows of railway data) · PostgreSQL / Supabase for accounts · Parquet for shipping</a:t>
+              <a:t>   Parquet (0.92 million rows), one train at a time · SQLite for development · PostgreSQL / Supabase for accounts</a:t>
             </a:r>
           </a:p>
         </p:txBody>
@@ -29654,7 +29658,7 @@
                   <a:srgbClr val="404040"/>
                 </a:solidFill>
               </a:rPr>
-              <a:t>   GitHub + Streamlit Community Cloud · secrets kept out of the code</a:t>
+              <a:t>   GitHub (tests + secret scan on every push) + Streamlit Community Cloud</a:t>
             </a:r>
           </a:p>
         </p:txBody>
@@ -32821,6 +32825,38 @@
               <a:t> (next slide).</a:t>
             </a:r>
           </a:p>
+          <a:p>
+            <a:pPr marL="0" indent="0">
+              <a:spcAft>
+                <a:spcPts val="500"/>
+              </a:spcAft>
+              <a:buNone/>
+            </a:pPr>
+            <a:r>
+              <a:rPr lang="en-US" sz="1350" dirty="0">
+                <a:solidFill>
+                  <a:srgbClr val="404040"/>
+                </a:solidFill>
+              </a:rPr>
+              <a:t>Trained with TensorFlow, </a:t>
+            </a:r>
+            <a:r>
+              <a:rPr lang="en-US" sz="1350" b="1" dirty="0">
+                <a:solidFill>
+                  <a:srgbClr val="5A8A0C"/>
+                </a:solidFill>
+              </a:rPr>
+              <a:t>runs on PyTorch</a:t>
+            </a:r>
+            <a:r>
+              <a:rPr lang="en-US" sz="1350" dirty="0">
+                <a:solidFill>
+                  <a:srgbClr val="404040"/>
+                </a:solidFill>
+              </a:rPr>
+              <a:t> in the app – same answers, less memory.</a:t>
+            </a:r>
+          </a:p>
         </p:txBody>
       </p:sp>
       <p:sp>
@@ -33115,7 +33151,7 @@
                   <a:srgbClr val="404040"/>
                 </a:solidFill>
               </a:rPr>
-              <a:t>CRAFT detector draws a box around each word</a:t>
+              <a:t>CRAFT detector boxes each word – once per photo, shared by all scripts</a:t>
             </a:r>
           </a:p>
         </p:txBody>
@@ -33694,6 +33730,1601 @@
                 </a:solidFill>
               </a:rPr>
               <a:t>the user can pick the station from candidates or a search box, and the journey planner never depends on a scan.</a:t>
+            </a:r>
+          </a:p>
+        </p:txBody>
+      </p:sp>
+    </p:spTree>
+  </p:cSld>
+  <p:clrMapOvr>
+    <a:masterClrMapping/>
+  </p:clrMapOvr>
+</p:sld>
+</file>
+
+<file path=ppt/slides/slide8.xml><?xml version="1.0" encoding="utf-8"?>
+<p:sld xmlns:a="http://schemas.openxmlformats.org/drawingml/2006/main" xmlns:r="http://schemas.openxmlformats.org/officeDocument/2006/relationships" xmlns:p="http://schemas.openxmlformats.org/presentationml/2006/main">
+  <p:cSld>
+    <p:spTree>
+      <p:nvGrpSpPr>
+        <p:cNvPr id="1" name=""/>
+        <p:cNvGrpSpPr/>
+        <p:nvPr/>
+      </p:nvGrpSpPr>
+      <p:grpSpPr>
+        <a:xfrm>
+          <a:off x="0" y="0"/>
+          <a:ext cx="0" cy="0"/>
+          <a:chOff x="0" y="0"/>
+          <a:chExt cx="0" cy="0"/>
+        </a:xfrm>
+      </p:grpSpPr>
+      <p:sp>
+        <p:nvSpPr>
+          <p:cNvPr id="2" name="Title 1"/>
+          <p:cNvSpPr>
+            <a:spLocks noGrp="1"/>
+          </p:cNvSpPr>
+          <p:nvPr>
+            <p:ph type="title"/>
+          </p:nvPr>
+        </p:nvSpPr>
+        <p:spPr/>
+        <p:txBody>
+          <a:bodyPr>
+            <a:normAutofit/>
+          </a:bodyPr>
+          <a:lstStyle/>
+          <a:p>
+            <a:r>
+              <a:rPr lang="en-US" dirty="0"/>
+              <a:t>Faster and lighter</a:t>
+            </a:r>
+          </a:p>
+        </p:txBody>
+      </p:sp>
+      <p:sp>
+        <p:nvSpPr>
+          <p:cNvPr id="226" name="Text"/>
+          <p:cNvSpPr/>
+          <p:nvPr/>
+        </p:nvSpPr>
+        <p:spPr>
+          <a:xfrm>
+            <a:off x="762000" y="1120000"/>
+            <a:ext cx="10668000" cy="350000"/>
+          </a:xfrm>
+          <a:prstGeom prst="rect">
+            <a:avLst/>
+          </a:prstGeom>
+          <a:noFill/>
+          <a:ln>
+            <a:noFill/>
+          </a:ln>
+        </p:spPr>
+        <p:txBody>
+          <a:bodyPr wrap="square" lIns="0" tIns="0" rIns="0" bIns="0" anchor="t">
+            <a:noAutofit/>
+          </a:bodyPr>
+          <a:lstStyle/>
+          <a:p>
+            <a:pPr marL="0" indent="0">
+              <a:buNone/>
+            </a:pPr>
+            <a:r>
+              <a:rPr lang="en-US" sz="1300" i="1" dirty="0">
+                <a:solidFill>
+                  <a:srgbClr val="595959"/>
+                </a:solidFill>
+              </a:rPr>
+              <a:t>Measured on a PC before and after the speed work, with server conditions simulated. The answers did not change – only the time and memory.</a:t>
+            </a:r>
+          </a:p>
+        </p:txBody>
+      </p:sp>
+      <p:sp>
+        <p:nvSpPr>
+          <p:cNvPr id="227" name="Text"/>
+          <p:cNvSpPr/>
+          <p:nvPr/>
+        </p:nvSpPr>
+        <p:spPr>
+          <a:xfrm>
+            <a:off x="762000" y="1770000"/>
+            <a:ext cx="3000000" cy="500000"/>
+          </a:xfrm>
+          <a:prstGeom prst="rect">
+            <a:avLst/>
+          </a:prstGeom>
+          <a:noFill/>
+          <a:ln>
+            <a:noFill/>
+          </a:ln>
+        </p:spPr>
+        <p:txBody>
+          <a:bodyPr wrap="square" lIns="0" tIns="0" rIns="0" bIns="0" anchor="ctr">
+            <a:noAutofit/>
+          </a:bodyPr>
+          <a:lstStyle/>
+          <a:p>
+            <a:pPr marL="0" indent="0">
+              <a:buNone/>
+            </a:pPr>
+            <a:r>
+              <a:rPr lang="en-US" sz="1400" b="1" dirty="0">
+                <a:solidFill>
+                  <a:srgbClr val="404040"/>
+                </a:solidFill>
+              </a:rPr>
+              <a:t>Log in → Scan page</a:t>
+            </a:r>
+          </a:p>
+        </p:txBody>
+      </p:sp>
+      <p:sp>
+        <p:nvSpPr>
+          <p:cNvPr id="228" name="Bar"/>
+          <p:cNvSpPr/>
+          <p:nvPr/>
+        </p:nvSpPr>
+        <p:spPr>
+          <a:xfrm>
+            <a:off x="3900000" y="1650000"/>
+            <a:ext cx="5300000" cy="330000"/>
+          </a:xfrm>
+          <a:prstGeom prst="roundRect">
+            <a:avLst>
+              <a:gd name="adj" fmla="val 25000"/>
+            </a:avLst>
+          </a:prstGeom>
+          <a:solidFill>
+            <a:srgbClr val="E7E6E6"/>
+          </a:solidFill>
+          <a:ln>
+            <a:noFill/>
+          </a:ln>
+        </p:spPr>
+        <p:txBody>
+          <a:bodyPr wrap="square" lIns="91440" tIns="0" rIns="91440" bIns="0" anchor="ctr">
+            <a:noAutofit/>
+          </a:bodyPr>
+          <a:lstStyle/>
+          <a:p>
+            <a:pPr marL="0" indent="0">
+              <a:buNone/>
+            </a:pPr>
+            <a:r>
+              <a:rPr lang="en-US" sz="1050" b="1" dirty="0">
+                <a:solidFill>
+                  <a:srgbClr val="595959"/>
+                </a:solidFill>
+              </a:rPr>
+              <a:t>BEFORE  279 s (waited for a database build)</a:t>
+            </a:r>
+          </a:p>
+        </p:txBody>
+      </p:sp>
+      <p:sp>
+        <p:nvSpPr>
+          <p:cNvPr id="229" name="Bar"/>
+          <p:cNvSpPr/>
+          <p:nvPr/>
+        </p:nvSpPr>
+        <p:spPr>
+          <a:xfrm>
+            <a:off x="3900000" y="2050000"/>
+            <a:ext cx="120000" cy="330000"/>
+          </a:xfrm>
+          <a:prstGeom prst="roundRect">
+            <a:avLst>
+              <a:gd name="adj" fmla="val 25000"/>
+            </a:avLst>
+          </a:prstGeom>
+          <a:solidFill>
+            <a:srgbClr val="5A8A0C"/>
+          </a:solidFill>
+          <a:ln>
+            <a:noFill/>
+          </a:ln>
+        </p:spPr>
+        <p:txBody>
+          <a:bodyPr wrap="square" lIns="228600" tIns="182880" rIns="228600" bIns="91440" anchor="t">
+            <a:noAutofit/>
+          </a:bodyPr>
+          <a:lstStyle/>
+          <a:p>
+            <a:endParaRPr lang="en-US"/>
+          </a:p>
+        </p:txBody>
+      </p:sp>
+      <p:sp>
+        <p:nvSpPr>
+          <p:cNvPr id="230" name="Text"/>
+          <p:cNvSpPr/>
+          <p:nvPr/>
+        </p:nvSpPr>
+        <p:spPr>
+          <a:xfrm>
+            <a:off x="4110000" y="2050000"/>
+            <a:ext cx="2400000" cy="330000"/>
+          </a:xfrm>
+          <a:prstGeom prst="rect">
+            <a:avLst/>
+          </a:prstGeom>
+          <a:noFill/>
+          <a:ln>
+            <a:noFill/>
+          </a:ln>
+        </p:spPr>
+        <p:txBody>
+          <a:bodyPr wrap="square" lIns="0" tIns="0" rIns="0" bIns="0" anchor="ctr">
+            <a:noAutofit/>
+          </a:bodyPr>
+          <a:lstStyle/>
+          <a:p>
+            <a:pPr marL="0" indent="0">
+              <a:buNone/>
+            </a:pPr>
+            <a:r>
+              <a:rPr lang="en-US" sz="1100" b="1" dirty="0">
+                <a:solidFill>
+                  <a:srgbClr val="5A8A0C"/>
+                </a:solidFill>
+              </a:rPr>
+              <a:t>NOW  0.7 s</a:t>
+            </a:r>
+          </a:p>
+        </p:txBody>
+      </p:sp>
+      <p:sp>
+        <p:nvSpPr>
+          <p:cNvPr id="231" name="Text"/>
+          <p:cNvSpPr/>
+          <p:nvPr/>
+        </p:nvSpPr>
+        <p:spPr>
+          <a:xfrm>
+            <a:off x="9350000" y="1830000"/>
+            <a:ext cx="2080000" cy="400000"/>
+          </a:xfrm>
+          <a:prstGeom prst="rect">
+            <a:avLst/>
+          </a:prstGeom>
+          <a:noFill/>
+          <a:ln>
+            <a:noFill/>
+          </a:ln>
+        </p:spPr>
+        <p:txBody>
+          <a:bodyPr wrap="square" lIns="0" tIns="0" rIns="0" bIns="0" anchor="ctr">
+            <a:noAutofit/>
+          </a:bodyPr>
+          <a:lstStyle/>
+          <a:p>
+            <a:pPr marL="0" indent="0" algn="r">
+              <a:buNone/>
+            </a:pPr>
+            <a:r>
+              <a:rPr lang="en-US" sz="1400" b="1" dirty="0">
+                <a:solidFill>
+                  <a:srgbClr val="5A8A0C"/>
+                </a:solidFill>
+              </a:rPr>
+              <a:t>✔ no wait</a:t>
+            </a:r>
+          </a:p>
+        </p:txBody>
+      </p:sp>
+      <p:sp>
+        <p:nvSpPr>
+          <p:cNvPr id="232" name="Text"/>
+          <p:cNvSpPr/>
+          <p:nvPr/>
+        </p:nvSpPr>
+        <p:spPr>
+          <a:xfrm>
+            <a:off x="762000" y="2700000"/>
+            <a:ext cx="3000000" cy="500000"/>
+          </a:xfrm>
+          <a:prstGeom prst="rect">
+            <a:avLst/>
+          </a:prstGeom>
+          <a:noFill/>
+          <a:ln>
+            <a:noFill/>
+          </a:ln>
+        </p:spPr>
+        <p:txBody>
+          <a:bodyPr wrap="square" lIns="0" tIns="0" rIns="0" bIns="0" anchor="ctr">
+            <a:noAutofit/>
+          </a:bodyPr>
+          <a:lstStyle/>
+          <a:p>
+            <a:pPr marL="0" indent="0">
+              <a:buNone/>
+            </a:pPr>
+            <a:r>
+              <a:rPr lang="en-US" sz="1400" b="1" dirty="0">
+                <a:solidFill>
+                  <a:srgbClr val="404040"/>
+                </a:solidFill>
+              </a:rPr>
+              <a:t>Delay estimate</a:t>
+            </a:r>
+          </a:p>
+        </p:txBody>
+      </p:sp>
+      <p:sp>
+        <p:nvSpPr>
+          <p:cNvPr id="233" name="Bar"/>
+          <p:cNvSpPr/>
+          <p:nvPr/>
+        </p:nvSpPr>
+        <p:spPr>
+          <a:xfrm>
+            <a:off x="3900000" y="2580000"/>
+            <a:ext cx="5300000" cy="330000"/>
+          </a:xfrm>
+          <a:prstGeom prst="roundRect">
+            <a:avLst>
+              <a:gd name="adj" fmla="val 25000"/>
+            </a:avLst>
+          </a:prstGeom>
+          <a:solidFill>
+            <a:srgbClr val="E7E6E6"/>
+          </a:solidFill>
+          <a:ln>
+            <a:noFill/>
+          </a:ln>
+        </p:spPr>
+        <p:txBody>
+          <a:bodyPr wrap="square" lIns="91440" tIns="0" rIns="91440" bIns="0" anchor="ctr">
+            <a:noAutofit/>
+          </a:bodyPr>
+          <a:lstStyle/>
+          <a:p>
+            <a:pPr marL="0" indent="0">
+              <a:buNone/>
+            </a:pPr>
+            <a:r>
+              <a:rPr lang="en-US" sz="1050" b="1" dirty="0">
+                <a:solidFill>
+                  <a:srgbClr val="595959"/>
+                </a:solidFill>
+              </a:rPr>
+              <a:t>BEFORE  26 s</a:t>
+            </a:r>
+          </a:p>
+        </p:txBody>
+      </p:sp>
+      <p:sp>
+        <p:nvSpPr>
+          <p:cNvPr id="234" name="Bar"/>
+          <p:cNvSpPr/>
+          <p:nvPr/>
+        </p:nvSpPr>
+        <p:spPr>
+          <a:xfrm>
+            <a:off x="3900000" y="2980000"/>
+            <a:ext cx="364122" cy="330000"/>
+          </a:xfrm>
+          <a:prstGeom prst="roundRect">
+            <a:avLst>
+              <a:gd name="adj" fmla="val 25000"/>
+            </a:avLst>
+          </a:prstGeom>
+          <a:solidFill>
+            <a:srgbClr val="5A8A0C"/>
+          </a:solidFill>
+          <a:ln>
+            <a:noFill/>
+          </a:ln>
+        </p:spPr>
+        <p:txBody>
+          <a:bodyPr wrap="square" lIns="228600" tIns="182880" rIns="228600" bIns="91440" anchor="t">
+            <a:noAutofit/>
+          </a:bodyPr>
+          <a:lstStyle/>
+          <a:p>
+            <a:endParaRPr lang="en-US"/>
+          </a:p>
+        </p:txBody>
+      </p:sp>
+      <p:sp>
+        <p:nvSpPr>
+          <p:cNvPr id="235" name="Text"/>
+          <p:cNvSpPr/>
+          <p:nvPr/>
+        </p:nvSpPr>
+        <p:spPr>
+          <a:xfrm>
+            <a:off x="4354122" y="2980000"/>
+            <a:ext cx="2400000" cy="330000"/>
+          </a:xfrm>
+          <a:prstGeom prst="rect">
+            <a:avLst/>
+          </a:prstGeom>
+          <a:noFill/>
+          <a:ln>
+            <a:noFill/>
+          </a:ln>
+        </p:spPr>
+        <p:txBody>
+          <a:bodyPr wrap="square" lIns="0" tIns="0" rIns="0" bIns="0" anchor="ctr">
+            <a:noAutofit/>
+          </a:bodyPr>
+          <a:lstStyle/>
+          <a:p>
+            <a:pPr marL="0" indent="0">
+              <a:buNone/>
+            </a:pPr>
+            <a:r>
+              <a:rPr lang="en-US" sz="1100" b="1" dirty="0">
+                <a:solidFill>
+                  <a:srgbClr val="5A8A0C"/>
+                </a:solidFill>
+              </a:rPr>
+              <a:t>NOW  1.8 s</a:t>
+            </a:r>
+          </a:p>
+        </p:txBody>
+      </p:sp>
+      <p:sp>
+        <p:nvSpPr>
+          <p:cNvPr id="236" name="Text"/>
+          <p:cNvSpPr/>
+          <p:nvPr/>
+        </p:nvSpPr>
+        <p:spPr>
+          <a:xfrm>
+            <a:off x="9350000" y="2760000"/>
+            <a:ext cx="2080000" cy="400000"/>
+          </a:xfrm>
+          <a:prstGeom prst="rect">
+            <a:avLst/>
+          </a:prstGeom>
+          <a:noFill/>
+          <a:ln>
+            <a:noFill/>
+          </a:ln>
+        </p:spPr>
+        <p:txBody>
+          <a:bodyPr wrap="square" lIns="0" tIns="0" rIns="0" bIns="0" anchor="ctr">
+            <a:noAutofit/>
+          </a:bodyPr>
+          <a:lstStyle/>
+          <a:p>
+            <a:pPr marL="0" indent="0" algn="r">
+              <a:buNone/>
+            </a:pPr>
+            <a:r>
+              <a:rPr lang="en-US" sz="1400" b="1" dirty="0">
+                <a:solidFill>
+                  <a:srgbClr val="5A8A0C"/>
+                </a:solidFill>
+              </a:rPr>
+              <a:t>✔ ~15× faster</a:t>
+            </a:r>
+          </a:p>
+        </p:txBody>
+      </p:sp>
+      <p:sp>
+        <p:nvSpPr>
+          <p:cNvPr id="237" name="Text"/>
+          <p:cNvSpPr/>
+          <p:nvPr/>
+        </p:nvSpPr>
+        <p:spPr>
+          <a:xfrm>
+            <a:off x="762000" y="3630000"/>
+            <a:ext cx="3000000" cy="500000"/>
+          </a:xfrm>
+          <a:prstGeom prst="rect">
+            <a:avLst/>
+          </a:prstGeom>
+          <a:noFill/>
+          <a:ln>
+            <a:noFill/>
+          </a:ln>
+        </p:spPr>
+        <p:txBody>
+          <a:bodyPr wrap="square" lIns="0" tIns="0" rIns="0" bIns="0" anchor="ctr">
+            <a:noAutofit/>
+          </a:bodyPr>
+          <a:lstStyle/>
+          <a:p>
+            <a:pPr marL="0" indent="0">
+              <a:buNone/>
+            </a:pPr>
+            <a:r>
+              <a:rPr lang="en-US" sz="1400" b="1" dirty="0">
+                <a:solidFill>
+                  <a:srgbClr val="404040"/>
+                </a:solidFill>
+              </a:rPr>
+              <a:t>Phone-photo scan (2 CPU threads)</a:t>
+            </a:r>
+          </a:p>
+        </p:txBody>
+      </p:sp>
+      <p:sp>
+        <p:nvSpPr>
+          <p:cNvPr id="238" name="Bar"/>
+          <p:cNvSpPr/>
+          <p:nvPr/>
+        </p:nvSpPr>
+        <p:spPr>
+          <a:xfrm>
+            <a:off x="3900000" y="3510000"/>
+            <a:ext cx="5300000" cy="330000"/>
+          </a:xfrm>
+          <a:prstGeom prst="roundRect">
+            <a:avLst>
+              <a:gd name="adj" fmla="val 25000"/>
+            </a:avLst>
+          </a:prstGeom>
+          <a:solidFill>
+            <a:srgbClr val="E7E6E6"/>
+          </a:solidFill>
+          <a:ln>
+            <a:noFill/>
+          </a:ln>
+        </p:spPr>
+        <p:txBody>
+          <a:bodyPr wrap="square" lIns="91440" tIns="0" rIns="91440" bIns="0" anchor="ctr">
+            <a:noAutofit/>
+          </a:bodyPr>
+          <a:lstStyle/>
+          <a:p>
+            <a:pPr marL="0" indent="0">
+              <a:buNone/>
+            </a:pPr>
+            <a:r>
+              <a:rPr lang="en-US" sz="1050" b="1" dirty="0">
+                <a:solidFill>
+                  <a:srgbClr val="595959"/>
+                </a:solidFill>
+              </a:rPr>
+              <a:t>BEFORE  72 s</a:t>
+            </a:r>
+          </a:p>
+        </p:txBody>
+      </p:sp>
+      <p:sp>
+        <p:nvSpPr>
+          <p:cNvPr id="239" name="Bar"/>
+          <p:cNvSpPr/>
+          <p:nvPr/>
+        </p:nvSpPr>
+        <p:spPr>
+          <a:xfrm>
+            <a:off x="3900000" y="3910000"/>
+            <a:ext cx="1461559" cy="330000"/>
+          </a:xfrm>
+          <a:prstGeom prst="roundRect">
+            <a:avLst>
+              <a:gd name="adj" fmla="val 25000"/>
+            </a:avLst>
+          </a:prstGeom>
+          <a:solidFill>
+            <a:srgbClr val="5A8A0C"/>
+          </a:solidFill>
+          <a:ln>
+            <a:noFill/>
+          </a:ln>
+        </p:spPr>
+        <p:txBody>
+          <a:bodyPr wrap="square" lIns="228600" tIns="182880" rIns="228600" bIns="91440" anchor="t">
+            <a:noAutofit/>
+          </a:bodyPr>
+          <a:lstStyle/>
+          <a:p>
+            <a:endParaRPr lang="en-US"/>
+          </a:p>
+        </p:txBody>
+      </p:sp>
+      <p:sp>
+        <p:nvSpPr>
+          <p:cNvPr id="240" name="Text"/>
+          <p:cNvSpPr/>
+          <p:nvPr/>
+        </p:nvSpPr>
+        <p:spPr>
+          <a:xfrm>
+            <a:off x="5451559" y="3910000"/>
+            <a:ext cx="2400000" cy="330000"/>
+          </a:xfrm>
+          <a:prstGeom prst="rect">
+            <a:avLst/>
+          </a:prstGeom>
+          <a:noFill/>
+          <a:ln>
+            <a:noFill/>
+          </a:ln>
+        </p:spPr>
+        <p:txBody>
+          <a:bodyPr wrap="square" lIns="0" tIns="0" rIns="0" bIns="0" anchor="ctr">
+            <a:noAutofit/>
+          </a:bodyPr>
+          <a:lstStyle/>
+          <a:p>
+            <a:pPr marL="0" indent="0">
+              <a:buNone/>
+            </a:pPr>
+            <a:r>
+              <a:rPr lang="en-US" sz="1100" b="1" dirty="0">
+                <a:solidFill>
+                  <a:srgbClr val="5A8A0C"/>
+                </a:solidFill>
+              </a:rPr>
+              <a:t>NOW  20 s</a:t>
+            </a:r>
+          </a:p>
+        </p:txBody>
+      </p:sp>
+      <p:sp>
+        <p:nvSpPr>
+          <p:cNvPr id="241" name="Text"/>
+          <p:cNvSpPr/>
+          <p:nvPr/>
+        </p:nvSpPr>
+        <p:spPr>
+          <a:xfrm>
+            <a:off x="9350000" y="3690000"/>
+            <a:ext cx="2080000" cy="400000"/>
+          </a:xfrm>
+          <a:prstGeom prst="rect">
+            <a:avLst/>
+          </a:prstGeom>
+          <a:noFill/>
+          <a:ln>
+            <a:noFill/>
+          </a:ln>
+        </p:spPr>
+        <p:txBody>
+          <a:bodyPr wrap="square" lIns="0" tIns="0" rIns="0" bIns="0" anchor="ctr">
+            <a:noAutofit/>
+          </a:bodyPr>
+          <a:lstStyle/>
+          <a:p>
+            <a:pPr marL="0" indent="0" algn="r">
+              <a:buNone/>
+            </a:pPr>
+            <a:r>
+              <a:rPr lang="en-US" sz="1400" b="1" dirty="0">
+                <a:solidFill>
+                  <a:srgbClr val="5A8A0C"/>
+                </a:solidFill>
+              </a:rPr>
+              <a:t>✔ ~3.6× faster</a:t>
+            </a:r>
+          </a:p>
+        </p:txBody>
+      </p:sp>
+      <p:sp>
+        <p:nvSpPr>
+          <p:cNvPr id="242" name="Text"/>
+          <p:cNvSpPr/>
+          <p:nvPr/>
+        </p:nvSpPr>
+        <p:spPr>
+          <a:xfrm>
+            <a:off x="762000" y="4560000"/>
+            <a:ext cx="3000000" cy="500000"/>
+          </a:xfrm>
+          <a:prstGeom prst="rect">
+            <a:avLst/>
+          </a:prstGeom>
+          <a:noFill/>
+          <a:ln>
+            <a:noFill/>
+          </a:ln>
+        </p:spPr>
+        <p:txBody>
+          <a:bodyPr wrap="square" lIns="0" tIns="0" rIns="0" bIns="0" anchor="ctr">
+            <a:noAutofit/>
+          </a:bodyPr>
+          <a:lstStyle/>
+          <a:p>
+            <a:pPr marL="0" indent="0">
+              <a:buNone/>
+            </a:pPr>
+            <a:r>
+              <a:rPr lang="en-US" sz="1400" b="1" dirty="0">
+                <a:solidFill>
+                  <a:srgbClr val="404040"/>
+                </a:solidFill>
+              </a:rPr>
+              <a:t>Peak memory during a scan</a:t>
+            </a:r>
+          </a:p>
+        </p:txBody>
+      </p:sp>
+      <p:sp>
+        <p:nvSpPr>
+          <p:cNvPr id="243" name="Bar"/>
+          <p:cNvSpPr/>
+          <p:nvPr/>
+        </p:nvSpPr>
+        <p:spPr>
+          <a:xfrm>
+            <a:off x="3900000" y="4440000"/>
+            <a:ext cx="5300000" cy="330000"/>
+          </a:xfrm>
+          <a:prstGeom prst="roundRect">
+            <a:avLst>
+              <a:gd name="adj" fmla="val 25000"/>
+            </a:avLst>
+          </a:prstGeom>
+          <a:solidFill>
+            <a:srgbClr val="E7E6E6"/>
+          </a:solidFill>
+          <a:ln>
+            <a:noFill/>
+          </a:ln>
+        </p:spPr>
+        <p:txBody>
+          <a:bodyPr wrap="square" lIns="91440" tIns="0" rIns="91440" bIns="0" anchor="ctr">
+            <a:noAutofit/>
+          </a:bodyPr>
+          <a:lstStyle/>
+          <a:p>
+            <a:pPr marL="0" indent="0">
+              <a:buNone/>
+            </a:pPr>
+            <a:r>
+              <a:rPr lang="en-US" sz="1050" b="1" dirty="0">
+                <a:solidFill>
+                  <a:srgbClr val="595959"/>
+                </a:solidFill>
+              </a:rPr>
+              <a:t>BEFORE  2.0 GB</a:t>
+            </a:r>
+          </a:p>
+        </p:txBody>
+      </p:sp>
+      <p:sp>
+        <p:nvSpPr>
+          <p:cNvPr id="244" name="Bar"/>
+          <p:cNvSpPr/>
+          <p:nvPr/>
+        </p:nvSpPr>
+        <p:spPr>
+          <a:xfrm>
+            <a:off x="3900000" y="4840000"/>
+            <a:ext cx="3793137" cy="330000"/>
+          </a:xfrm>
+          <a:prstGeom prst="roundRect">
+            <a:avLst>
+              <a:gd name="adj" fmla="val 25000"/>
+            </a:avLst>
+          </a:prstGeom>
+          <a:solidFill>
+            <a:srgbClr val="5A8A0C"/>
+          </a:solidFill>
+          <a:ln>
+            <a:noFill/>
+          </a:ln>
+        </p:spPr>
+        <p:txBody>
+          <a:bodyPr wrap="square" lIns="228600" tIns="182880" rIns="228600" bIns="91440" anchor="t">
+            <a:noAutofit/>
+          </a:bodyPr>
+          <a:lstStyle/>
+          <a:p>
+            <a:endParaRPr lang="en-US"/>
+          </a:p>
+        </p:txBody>
+      </p:sp>
+      <p:sp>
+        <p:nvSpPr>
+          <p:cNvPr id="245" name="Text"/>
+          <p:cNvSpPr/>
+          <p:nvPr/>
+        </p:nvSpPr>
+        <p:spPr>
+          <a:xfrm>
+            <a:off x="7783137" y="4840000"/>
+            <a:ext cx="2400000" cy="330000"/>
+          </a:xfrm>
+          <a:prstGeom prst="rect">
+            <a:avLst/>
+          </a:prstGeom>
+          <a:noFill/>
+          <a:ln>
+            <a:noFill/>
+          </a:ln>
+        </p:spPr>
+        <p:txBody>
+          <a:bodyPr wrap="square" lIns="0" tIns="0" rIns="0" bIns="0" anchor="ctr">
+            <a:noAutofit/>
+          </a:bodyPr>
+          <a:lstStyle/>
+          <a:p>
+            <a:pPr marL="0" indent="0">
+              <a:buNone/>
+            </a:pPr>
+            <a:r>
+              <a:rPr lang="en-US" sz="1100" b="1" dirty="0">
+                <a:solidFill>
+                  <a:srgbClr val="5A8A0C"/>
+                </a:solidFill>
+              </a:rPr>
+              <a:t>NOW  1.5 GB</a:t>
+            </a:r>
+          </a:p>
+        </p:txBody>
+      </p:sp>
+      <p:sp>
+        <p:nvSpPr>
+          <p:cNvPr id="246" name="Text"/>
+          <p:cNvSpPr/>
+          <p:nvPr/>
+        </p:nvSpPr>
+        <p:spPr>
+          <a:xfrm>
+            <a:off x="9350000" y="4620000"/>
+            <a:ext cx="2080000" cy="400000"/>
+          </a:xfrm>
+          <a:prstGeom prst="rect">
+            <a:avLst/>
+          </a:prstGeom>
+          <a:noFill/>
+          <a:ln>
+            <a:noFill/>
+          </a:ln>
+        </p:spPr>
+        <p:txBody>
+          <a:bodyPr wrap="square" lIns="0" tIns="0" rIns="0" bIns="0" anchor="ctr">
+            <a:noAutofit/>
+          </a:bodyPr>
+          <a:lstStyle/>
+          <a:p>
+            <a:pPr marL="0" indent="0" algn="r">
+              <a:buNone/>
+            </a:pPr>
+            <a:r>
+              <a:rPr lang="en-US" sz="1400" b="1" dirty="0">
+                <a:solidFill>
+                  <a:srgbClr val="5A8A0C"/>
+                </a:solidFill>
+              </a:rPr>
+              <a:t>✔ −28%</a:t>
+            </a:r>
+          </a:p>
+        </p:txBody>
+      </p:sp>
+      <p:sp>
+        <p:nvSpPr>
+          <p:cNvPr id="247" name="Shape"/>
+          <p:cNvSpPr/>
+          <p:nvPr/>
+        </p:nvSpPr>
+        <p:spPr>
+          <a:xfrm>
+            <a:off x="762000" y="5450000"/>
+            <a:ext cx="10668000" cy="650000"/>
+          </a:xfrm>
+          <a:prstGeom prst="roundRect">
+            <a:avLst>
+              <a:gd name="adj" fmla="val 12000"/>
+            </a:avLst>
+          </a:prstGeom>
+          <a:solidFill>
+            <a:srgbClr val="EAF2DC"/>
+          </a:solidFill>
+          <a:ln w="12700">
+            <a:solidFill>
+              <a:srgbClr val="5A8A0C"/>
+            </a:solidFill>
+          </a:ln>
+        </p:spPr>
+        <p:txBody>
+          <a:bodyPr wrap="square" lIns="274320" tIns="45720" rIns="274320" bIns="45720" anchor="ctr">
+            <a:noAutofit/>
+          </a:bodyPr>
+          <a:lstStyle/>
+          <a:p>
+            <a:pPr marL="0" indent="0">
+              <a:buNone/>
+            </a:pPr>
+            <a:r>
+              <a:rPr lang="en-US" sz="1400" b="1" dirty="0">
+                <a:solidFill>
+                  <a:srgbClr val="5A8A0C"/>
+                </a:solidFill>
+              </a:rPr>
+              <a:t>HOW: </a:t>
+            </a:r>
+            <a:r>
+              <a:rPr lang="en-US" sz="1400" dirty="0">
+                <a:solidFill>
+                  <a:srgbClr val="404040"/>
+                </a:solidFill>
+              </a:rPr>
+              <a:t>TensorFlow removed, one text detector shared by all scripts, train data read one train at a time instead of a 4–5 minute database build, and a slow map step fixed.</a:t>
+            </a:r>
+          </a:p>
+        </p:txBody>
+      </p:sp>
+    </p:spTree>
+  </p:cSld>
+  <p:clrMapOvr>
+    <a:masterClrMapping/>
+  </p:clrMapOvr>
+</p:sld>
+</file>
+
+<file path=ppt/slides/slide9.xml><?xml version="1.0" encoding="utf-8"?>
+<p:sld xmlns:a="http://schemas.openxmlformats.org/drawingml/2006/main" xmlns:r="http://schemas.openxmlformats.org/officeDocument/2006/relationships" xmlns:p="http://schemas.openxmlformats.org/presentationml/2006/main">
+  <p:cSld>
+    <p:spTree>
+      <p:nvGrpSpPr>
+        <p:cNvPr id="1" name=""/>
+        <p:cNvGrpSpPr/>
+        <p:nvPr/>
+      </p:nvGrpSpPr>
+      <p:grpSpPr>
+        <a:xfrm>
+          <a:off x="0" y="0"/>
+          <a:ext cx="0" cy="0"/>
+          <a:chOff x="0" y="0"/>
+          <a:chExt cx="0" cy="0"/>
+        </a:xfrm>
+      </p:grpSpPr>
+      <p:sp>
+        <p:nvSpPr>
+          <p:cNvPr id="2" name="Title 1"/>
+          <p:cNvSpPr>
+            <a:spLocks noGrp="1"/>
+          </p:cNvSpPr>
+          <p:nvPr>
+            <p:ph type="title"/>
+          </p:nvPr>
+        </p:nvSpPr>
+        <p:spPr/>
+        <p:txBody>
+          <a:bodyPr>
+            <a:normAutofit/>
+          </a:bodyPr>
+          <a:lstStyle/>
+          <a:p>
+            <a:r>
+              <a:rPr lang="en-US" dirty="0"/>
+              <a:t>Safe and private by design</a:t>
+            </a:r>
+          </a:p>
+        </p:txBody>
+      </p:sp>
+      <p:sp>
+        <p:nvSpPr>
+          <p:cNvPr id="248" name="Text"/>
+          <p:cNvSpPr/>
+          <p:nvPr/>
+        </p:nvSpPr>
+        <p:spPr>
+          <a:xfrm>
+            <a:off x="762000" y="1120000"/>
+            <a:ext cx="10668000" cy="350000"/>
+          </a:xfrm>
+          <a:prstGeom prst="rect">
+            <a:avLst/>
+          </a:prstGeom>
+          <a:noFill/>
+          <a:ln>
+            <a:noFill/>
+          </a:ln>
+        </p:spPr>
+        <p:txBody>
+          <a:bodyPr wrap="square" lIns="0" tIns="0" rIns="0" bIns="0" anchor="t">
+            <a:noAutofit/>
+          </a:bodyPr>
+          <a:lstStyle/>
+          <a:p>
+            <a:pPr marL="0" indent="0">
+              <a:buNone/>
+            </a:pPr>
+            <a:r>
+              <a:rPr lang="en-US" sz="1300" i="1" dirty="0">
+                <a:solidFill>
+                  <a:srgbClr val="595959"/>
+                </a:solidFill>
+              </a:rPr>
+              <a:t>What protects the app, its users and their data.</a:t>
+            </a:r>
+          </a:p>
+        </p:txBody>
+      </p:sp>
+      <p:sp>
+        <p:nvSpPr>
+          <p:cNvPr id="249" name="Shape"/>
+          <p:cNvSpPr/>
+          <p:nvPr/>
+        </p:nvSpPr>
+        <p:spPr>
+          <a:xfrm>
+            <a:off x="762000" y="1900000"/>
+            <a:ext cx="3400000" cy="3000000"/>
+          </a:xfrm>
+          <a:prstGeom prst="roundRect">
+            <a:avLst>
+              <a:gd name="adj" fmla="val 6000"/>
+            </a:avLst>
+          </a:prstGeom>
+          <a:solidFill>
+            <a:srgbClr val="DDEDF4"/>
+          </a:solidFill>
+          <a:ln w="19050">
+            <a:solidFill>
+              <a:srgbClr val="0E6489"/>
+            </a:solidFill>
+          </a:ln>
+        </p:spPr>
+        <p:txBody>
+          <a:bodyPr wrap="square" lIns="228600" tIns="440000" rIns="228600" bIns="91440" anchor="t">
+            <a:noAutofit/>
+          </a:bodyPr>
+          <a:lstStyle/>
+          <a:p>
+            <a:pPr marL="0" indent="0">
+              <a:spcAft>
+                <a:spcPts val="600"/>
+              </a:spcAft>
+              <a:buNone/>
+            </a:pPr>
+            <a:r>
+              <a:rPr lang="en-US" sz="1500" b="1" dirty="0">
+                <a:solidFill>
+                  <a:srgbClr val="0E6489"/>
+                </a:solidFill>
+              </a:rPr>
+              <a:t>PROTECTS THE APP</a:t>
+            </a:r>
+          </a:p>
+          <a:p>
+            <a:pPr marL="0" indent="0">
+              <a:spcAft>
+                <a:spcPts val="700"/>
+              </a:spcAft>
+              <a:buNone/>
+            </a:pPr>
+            <a:r>
+              <a:rPr lang="en-US" sz="1350" b="1" dirty="0">
+                <a:solidFill>
+                  <a:srgbClr val="0E6489"/>
+                </a:solidFill>
+              </a:rPr>
+              <a:t>10 scans per 10 minutes</a:t>
+            </a:r>
+            <a:r>
+              <a:rPr lang="en-US" sz="1350" dirty="0">
+                <a:solidFill>
+                  <a:srgbClr val="404040"/>
+                </a:solidFill>
+              </a:rPr>
+              <a:t> per user and </a:t>
+            </a:r>
+            <a:r>
+              <a:rPr lang="en-US" sz="1350" b="1" dirty="0">
+                <a:solidFill>
+                  <a:srgbClr val="0E6489"/>
+                </a:solidFill>
+              </a:rPr>
+              <a:t>5 sign-ups per hour</a:t>
+            </a:r>
+            <a:r>
+              <a:rPr lang="en-US" sz="1350" dirty="0">
+                <a:solidFill>
+                  <a:srgbClr val="404040"/>
+                </a:solidFill>
+              </a:rPr>
+              <a:t> per address – limits stored in the database.</a:t>
+            </a:r>
+          </a:p>
+          <a:p>
+            <a:pPr marL="0" indent="0">
+              <a:spcAft>
+                <a:spcPts val="700"/>
+              </a:spcAft>
+              <a:buNone/>
+            </a:pPr>
+            <a:r>
+              <a:rPr lang="en-US" sz="1350" dirty="0">
+                <a:solidFill>
+                  <a:srgbClr val="404040"/>
+                </a:solidFill>
+              </a:rPr>
+              <a:t>Uploads up to 10 MB; photos over 60 megapixels are refused </a:t>
+            </a:r>
+            <a:r>
+              <a:rPr lang="en-US" sz="1350" b="1" dirty="0">
+                <a:solidFill>
+                  <a:srgbClr val="0E6489"/>
+                </a:solidFill>
+              </a:rPr>
+              <a:t>before decoding</a:t>
+            </a:r>
+            <a:r>
+              <a:rPr lang="en-US" sz="1350" dirty="0">
+                <a:solidFill>
+                  <a:srgbClr val="404040"/>
+                </a:solidFill>
+              </a:rPr>
+              <a:t>.</a:t>
+            </a:r>
+          </a:p>
+        </p:txBody>
+      </p:sp>
+      <p:sp>
+        <p:nvSpPr>
+          <p:cNvPr id="250" name="Circle"/>
+          <p:cNvSpPr/>
+          <p:nvPr/>
+        </p:nvSpPr>
+        <p:spPr>
+          <a:xfrm>
+            <a:off x="2182000" y="1620000"/>
+            <a:ext cx="560000" cy="560000"/>
+          </a:xfrm>
+          <a:prstGeom prst="ellipse">
+            <a:avLst/>
+          </a:prstGeom>
+          <a:solidFill>
+            <a:srgbClr val="0E6489"/>
+          </a:solidFill>
+          <a:ln>
+            <a:noFill/>
+          </a:ln>
+        </p:spPr>
+        <p:txBody>
+          <a:bodyPr wrap="square" lIns="0" tIns="0" rIns="0" bIns="0" anchor="ctr">
+            <a:noAutofit/>
+          </a:bodyPr>
+          <a:lstStyle/>
+          <a:p>
+            <a:endParaRPr lang="en-US"/>
+          </a:p>
+        </p:txBody>
+      </p:sp>
+      <p:pic>
+        <p:nvPicPr>
+          <p:cNvPr id="251" name="Icon" descr="shield_white icon"/>
+          <p:cNvPicPr>
+            <a:picLocks noChangeAspect="1"/>
+          </p:cNvPicPr>
+          <p:nvPr/>
+        </p:nvPicPr>
+        <p:blipFill>
+          <a:blip r:embed="rId2"/>
+          <a:stretch>
+            <a:fillRect/>
+          </a:stretch>
+        </p:blipFill>
+        <p:spPr>
+          <a:xfrm>
+            <a:off x="2308000" y="1746000"/>
+            <a:ext cx="308000" cy="308000"/>
+          </a:xfrm>
+          <a:prstGeom prst="rect">
+            <a:avLst/>
+          </a:prstGeom>
+        </p:spPr>
+      </p:pic>
+      <p:sp>
+        <p:nvSpPr>
+          <p:cNvPr id="252" name="Shape"/>
+          <p:cNvSpPr/>
+          <p:nvPr/>
+        </p:nvSpPr>
+        <p:spPr>
+          <a:xfrm>
+            <a:off x="4396000" y="1900000"/>
+            <a:ext cx="3400000" cy="3000000"/>
+          </a:xfrm>
+          <a:prstGeom prst="roundRect">
+            <a:avLst>
+              <a:gd name="adj" fmla="val 6000"/>
+            </a:avLst>
+          </a:prstGeom>
+          <a:solidFill>
+            <a:srgbClr val="ECE5F5"/>
+          </a:solidFill>
+          <a:ln w="19050">
+            <a:solidFill>
+              <a:srgbClr val="5B2E91"/>
+            </a:solidFill>
+          </a:ln>
+        </p:spPr>
+        <p:txBody>
+          <a:bodyPr wrap="square" lIns="228600" tIns="440000" rIns="228600" bIns="91440" anchor="t">
+            <a:noAutofit/>
+          </a:bodyPr>
+          <a:lstStyle/>
+          <a:p>
+            <a:pPr marL="0" indent="0">
+              <a:spcAft>
+                <a:spcPts val="600"/>
+              </a:spcAft>
+              <a:buNone/>
+            </a:pPr>
+            <a:r>
+              <a:rPr lang="en-US" sz="1500" b="1" dirty="0">
+                <a:solidFill>
+                  <a:srgbClr val="5B2E91"/>
+                </a:solidFill>
+              </a:rPr>
+              <a:t>PROTECTS USERS</a:t>
+            </a:r>
+          </a:p>
+          <a:p>
+            <a:pPr marL="0" indent="0">
+              <a:spcAft>
+                <a:spcPts val="700"/>
+              </a:spcAft>
+              <a:buNone/>
+            </a:pPr>
+            <a:r>
+              <a:rPr lang="en-US" sz="1350" dirty="0">
+                <a:solidFill>
+                  <a:srgbClr val="404040"/>
+                </a:solidFill>
+              </a:rPr>
+              <a:t>Passwords stored only as </a:t>
+            </a:r>
+            <a:r>
+              <a:rPr lang="en-US" sz="1350" b="1" dirty="0">
+                <a:solidFill>
+                  <a:srgbClr val="5B2E91"/>
+                </a:solidFill>
+              </a:rPr>
+              <a:t>salted scrypt hashes</a:t>
+            </a:r>
+            <a:r>
+              <a:rPr lang="en-US" sz="1350" dirty="0">
+                <a:solidFill>
+                  <a:srgbClr val="404040"/>
+                </a:solidFill>
+              </a:rPr>
+              <a:t>; lockout after 5 wrong tries.</a:t>
+            </a:r>
+          </a:p>
+          <a:p>
+            <a:pPr marL="0" indent="0">
+              <a:spcAft>
+                <a:spcPts val="700"/>
+              </a:spcAft>
+              <a:buNone/>
+            </a:pPr>
+            <a:r>
+              <a:rPr lang="en-US" sz="1350" dirty="0">
+                <a:solidFill>
+                  <a:srgbClr val="404040"/>
+                </a:solidFill>
+              </a:rPr>
+              <a:t>Photos are </a:t>
+            </a:r>
+            <a:r>
+              <a:rPr lang="en-US" sz="1350" b="1" dirty="0">
+                <a:solidFill>
+                  <a:srgbClr val="5B2E91"/>
+                </a:solidFill>
+              </a:rPr>
+              <a:t>never stored</a:t>
+            </a:r>
+            <a:r>
+              <a:rPr lang="en-US" sz="1350" dirty="0">
+                <a:solidFill>
+                  <a:srgbClr val="404040"/>
+                </a:solidFill>
+              </a:rPr>
+              <a:t>. Users can </a:t>
+            </a:r>
+            <a:r>
+              <a:rPr lang="en-US" sz="1350" b="1" dirty="0">
+                <a:solidFill>
+                  <a:srgbClr val="5B2E91"/>
+                </a:solidFill>
+              </a:rPr>
+              <a:t>download</a:t>
+            </a:r>
+            <a:r>
+              <a:rPr lang="en-US" sz="1350" dirty="0">
+                <a:solidFill>
+                  <a:srgbClr val="404040"/>
+                </a:solidFill>
+              </a:rPr>
+              <a:t> all their data or </a:t>
+            </a:r>
+            <a:r>
+              <a:rPr lang="en-US" sz="1350" b="1" dirty="0">
+                <a:solidFill>
+                  <a:srgbClr val="5B2E91"/>
+                </a:solidFill>
+              </a:rPr>
+              <a:t>delete</a:t>
+            </a:r>
+            <a:r>
+              <a:rPr lang="en-US" sz="1350" dirty="0">
+                <a:solidFill>
+                  <a:srgbClr val="404040"/>
+                </a:solidFill>
+              </a:rPr>
+              <a:t> their account.</a:t>
+            </a:r>
+          </a:p>
+        </p:txBody>
+      </p:sp>
+      <p:sp>
+        <p:nvSpPr>
+          <p:cNvPr id="253" name="Circle"/>
+          <p:cNvSpPr/>
+          <p:nvPr/>
+        </p:nvSpPr>
+        <p:spPr>
+          <a:xfrm>
+            <a:off x="5816000" y="1620000"/>
+            <a:ext cx="560000" cy="560000"/>
+          </a:xfrm>
+          <a:prstGeom prst="ellipse">
+            <a:avLst/>
+          </a:prstGeom>
+          <a:solidFill>
+            <a:srgbClr val="5B2E91"/>
+          </a:solidFill>
+          <a:ln>
+            <a:noFill/>
+          </a:ln>
+        </p:spPr>
+        <p:txBody>
+          <a:bodyPr wrap="square" lIns="0" tIns="0" rIns="0" bIns="0" anchor="ctr">
+            <a:noAutofit/>
+          </a:bodyPr>
+          <a:lstStyle/>
+          <a:p>
+            <a:endParaRPr lang="en-US"/>
+          </a:p>
+        </p:txBody>
+      </p:sp>
+      <p:pic>
+        <p:nvPicPr>
+          <p:cNvPr id="254" name="Icon" descr="lock_white icon"/>
+          <p:cNvPicPr>
+            <a:picLocks noChangeAspect="1"/>
+          </p:cNvPicPr>
+          <p:nvPr/>
+        </p:nvPicPr>
+        <p:blipFill>
+          <a:blip r:embed="rId3"/>
+          <a:stretch>
+            <a:fillRect/>
+          </a:stretch>
+        </p:blipFill>
+        <p:spPr>
+          <a:xfrm>
+            <a:off x="5942000" y="1746000"/>
+            <a:ext cx="308000" cy="308000"/>
+          </a:xfrm>
+          <a:prstGeom prst="rect">
+            <a:avLst/>
+          </a:prstGeom>
+        </p:spPr>
+      </p:pic>
+      <p:sp>
+        <p:nvSpPr>
+          <p:cNvPr id="255" name="Shape"/>
+          <p:cNvSpPr/>
+          <p:nvPr/>
+        </p:nvSpPr>
+        <p:spPr>
+          <a:xfrm>
+            <a:off x="8030000" y="1900000"/>
+            <a:ext cx="3400000" cy="3000000"/>
+          </a:xfrm>
+          <a:prstGeom prst="roundRect">
+            <a:avLst>
+              <a:gd name="adj" fmla="val 6000"/>
+            </a:avLst>
+          </a:prstGeom>
+          <a:solidFill>
+            <a:srgbClr val="EAF2DC"/>
+          </a:solidFill>
+          <a:ln w="19050">
+            <a:solidFill>
+              <a:srgbClr val="5A8A0C"/>
+            </a:solidFill>
+          </a:ln>
+        </p:spPr>
+        <p:txBody>
+          <a:bodyPr wrap="square" lIns="228600" tIns="440000" rIns="228600" bIns="91440" anchor="t">
+            <a:noAutofit/>
+          </a:bodyPr>
+          <a:lstStyle/>
+          <a:p>
+            <a:pPr marL="0" indent="0">
+              <a:spcAft>
+                <a:spcPts val="600"/>
+              </a:spcAft>
+              <a:buNone/>
+            </a:pPr>
+            <a:r>
+              <a:rPr lang="en-US" sz="1500" b="1" dirty="0">
+                <a:solidFill>
+                  <a:srgbClr val="5A8A0C"/>
+                </a:solidFill>
+              </a:rPr>
+              <a:t>KEEPS IT RUNNING</a:t>
+            </a:r>
+          </a:p>
+          <a:p>
+            <a:pPr marL="0" indent="0">
+              <a:spcAft>
+                <a:spcPts val="700"/>
+              </a:spcAft>
+              <a:buNone/>
+            </a:pPr>
+            <a:r>
+              <a:rPr lang="en-US" sz="1350" dirty="0">
+                <a:solidFill>
+                  <a:srgbClr val="404040"/>
+                </a:solidFill>
+              </a:rPr>
+              <a:t>Every push: </a:t>
+            </a:r>
+            <a:r>
+              <a:rPr lang="en-US" sz="1350" b="1" dirty="0">
+                <a:solidFill>
+                  <a:srgbClr val="5A8A0C"/>
+                </a:solidFill>
+              </a:rPr>
+              <a:t>374 automated tests</a:t>
+            </a:r>
+            <a:r>
+              <a:rPr lang="en-US" sz="1350" dirty="0">
+                <a:solidFill>
+                  <a:srgbClr val="404040"/>
+                </a:solidFill>
+              </a:rPr>
+              <a:t>, lint and a secret scan on GitHub.</a:t>
+            </a:r>
+          </a:p>
+          <a:p>
+            <a:pPr marL="0" indent="0">
+              <a:spcAft>
+                <a:spcPts val="700"/>
+              </a:spcAft>
+              <a:buNone/>
+            </a:pPr>
+            <a:r>
+              <a:rPr lang="en-US" sz="1350" dirty="0">
+                <a:solidFill>
+                  <a:srgbClr val="404040"/>
+                </a:solidFill>
+              </a:rPr>
+              <a:t>Logs with passwords and e-mails removed; </a:t>
+            </a:r>
+            <a:r>
+              <a:rPr lang="en-US" sz="1350" b="1" dirty="0">
+                <a:solidFill>
+                  <a:srgbClr val="5A8A0C"/>
+                </a:solidFill>
+              </a:rPr>
+              <a:t>account backups</a:t>
+            </a:r>
+            <a:r>
+              <a:rPr lang="en-US" sz="1350" dirty="0">
+                <a:solidFill>
+                  <a:srgbClr val="404040"/>
+                </a:solidFill>
+              </a:rPr>
+              <a:t> with a tested restore; runbooks for incidents.</a:t>
+            </a:r>
+          </a:p>
+        </p:txBody>
+      </p:sp>
+      <p:sp>
+        <p:nvSpPr>
+          <p:cNvPr id="256" name="Circle"/>
+          <p:cNvSpPr/>
+          <p:nvPr/>
+        </p:nvSpPr>
+        <p:spPr>
+          <a:xfrm>
+            <a:off x="9450000" y="1620000"/>
+            <a:ext cx="560000" cy="560000"/>
+          </a:xfrm>
+          <a:prstGeom prst="ellipse">
+            <a:avLst/>
+          </a:prstGeom>
+          <a:solidFill>
+            <a:srgbClr val="5A8A0C"/>
+          </a:solidFill>
+          <a:ln>
+            <a:noFill/>
+          </a:ln>
+        </p:spPr>
+        <p:txBody>
+          <a:bodyPr wrap="square" lIns="0" tIns="0" rIns="0" bIns="0" anchor="ctr">
+            <a:noAutofit/>
+          </a:bodyPr>
+          <a:lstStyle/>
+          <a:p>
+            <a:endParaRPr lang="en-US"/>
+          </a:p>
+        </p:txBody>
+      </p:sp>
+      <p:pic>
+        <p:nvPicPr>
+          <p:cNvPr id="257" name="Icon" descr="tools_white icon"/>
+          <p:cNvPicPr>
+            <a:picLocks noChangeAspect="1"/>
+          </p:cNvPicPr>
+          <p:nvPr/>
+        </p:nvPicPr>
+        <p:blipFill>
+          <a:blip r:embed="rId4"/>
+          <a:stretch>
+            <a:fillRect/>
+          </a:stretch>
+        </p:blipFill>
+        <p:spPr>
+          <a:xfrm>
+            <a:off x="9576000" y="1746000"/>
+            <a:ext cx="308000" cy="308000"/>
+          </a:xfrm>
+          <a:prstGeom prst="rect">
+            <a:avLst/>
+          </a:prstGeom>
+        </p:spPr>
+      </p:pic>
+      <p:sp>
+        <p:nvSpPr>
+          <p:cNvPr id="258" name="Shape"/>
+          <p:cNvSpPr/>
+          <p:nvPr/>
+        </p:nvSpPr>
+        <p:spPr>
+          <a:xfrm>
+            <a:off x="762000" y="5200000"/>
+            <a:ext cx="10668000" cy="650000"/>
+          </a:xfrm>
+          <a:prstGeom prst="roundRect">
+            <a:avLst>
+              <a:gd name="adj" fmla="val 12000"/>
+            </a:avLst>
+          </a:prstGeom>
+          <a:solidFill>
+            <a:srgbClr val="FDF3D1"/>
+          </a:solidFill>
+          <a:ln w="12700">
+            <a:solidFill>
+              <a:srgbClr val="B8860B"/>
+            </a:solidFill>
+          </a:ln>
+        </p:spPr>
+        <p:txBody>
+          <a:bodyPr wrap="square" lIns="274320" tIns="45720" rIns="274320" bIns="45720" anchor="ctr">
+            <a:noAutofit/>
+          </a:bodyPr>
+          <a:lstStyle/>
+          <a:p>
+            <a:pPr marL="0" indent="0">
+              <a:buNone/>
+            </a:pPr>
+            <a:r>
+              <a:rPr lang="en-US" sz="1400" b="1" dirty="0">
+                <a:solidFill>
+                  <a:srgbClr val="9A6E00"/>
+                </a:solidFill>
+              </a:rPr>
+              <a:t>STILL OPEN: </a:t>
+            </a:r>
+            <a:r>
+              <a:rPr lang="en-US" sz="1400" dirty="0">
+                <a:solidFill>
+                  <a:srgbClr val="404040"/>
+                </a:solidFill>
+              </a:rPr>
+              <a:t>no e-mail verification or password reset yet – the next decision is whether to move log-in to a managed service such as Supabase Auth.</a:t>
             </a:r>
           </a:p>
         </p:txBody>
@@ -37012,21 +38643,6 @@
 </file>
 
 <file path=customXml/item1.xml><?xml version="1.0" encoding="utf-8"?>
-<p:properties xmlns:p="http://schemas.microsoft.com/office/2006/metadata/properties" xmlns:xsi="http://www.w3.org/2001/XMLSchema-instance" xmlns:pc="http://schemas.microsoft.com/office/infopath/2007/PartnerControls">
-  <documentManagement/>
-</p:properties>
-</file>
-
-<file path=customXml/item2.xml><?xml version="1.0" encoding="utf-8"?>
-<?mso-contentType ?>
-<FormTemplates xmlns="http://schemas.microsoft.com/sharepoint/v3/contenttype/forms">
-  <Display>DocumentLibraryForm</Display>
-  <Edit>DocumentLibraryForm</Edit>
-  <New>DocumentLibraryForm</New>
-</FormTemplates>
-</file>
-
-<file path=customXml/item3.xml><?xml version="1.0" encoding="utf-8"?>
 <ct:contentTypeSchema xmlns:ct="http://schemas.microsoft.com/office/2006/metadata/contentType" xmlns:ma="http://schemas.microsoft.com/office/2006/metadata/properties/metaAttributes" ct:_="" ma:_="" ma:contentTypeName="Document" ma:contentTypeID="0x010100F36C591950F67340A1A0FD1599A6C1CE" ma:contentTypeVersion="0" ma:contentTypeDescription="Create a new document." ma:contentTypeScope="" ma:versionID="1f4abe6911a64b09b1a76a07b62e316a">
   <xsd:schema xmlns:xsd="http://www.w3.org/2001/XMLSchema" xmlns:xs="http://www.w3.org/2001/XMLSchema" xmlns:p="http://schemas.microsoft.com/office/2006/metadata/properties" targetNamespace="http://schemas.microsoft.com/office/2006/metadata/properties" ma:root="true" ma:fieldsID="1b05d82d297216baf5b26c55225140df">
     <xsd:element name="properties">
@@ -37140,7 +38756,38 @@
 </ct:contentTypeSchema>
 </file>
 
+<file path=customXml/item2.xml><?xml version="1.0" encoding="utf-8"?>
+<p:properties xmlns:p="http://schemas.microsoft.com/office/2006/metadata/properties" xmlns:xsi="http://www.w3.org/2001/XMLSchema-instance" xmlns:pc="http://schemas.microsoft.com/office/infopath/2007/PartnerControls">
+  <documentManagement/>
+</p:properties>
+</file>
+
+<file path=customXml/item3.xml><?xml version="1.0" encoding="utf-8"?>
+<?mso-contentType ?>
+<FormTemplates xmlns="http://schemas.microsoft.com/sharepoint/v3/contenttype/forms">
+  <Display>DocumentLibraryForm</Display>
+  <Edit>DocumentLibraryForm</Edit>
+  <New>DocumentLibraryForm</New>
+</FormTemplates>
+</file>
+
 <file path=customXml/itemProps1.xml><?xml version="1.0" encoding="utf-8"?>
+<ds:datastoreItem xmlns:ds="http://schemas.openxmlformats.org/officeDocument/2006/customXml" ds:itemID="{7A5F66AF-335A-4B7B-A5ED-C6A0F99985B0}">
+  <ds:schemaRefs>
+    <ds:schemaRef ds:uri="http://schemas.microsoft.com/office/2006/metadata/contentType"/>
+    <ds:schemaRef ds:uri="http://schemas.microsoft.com/office/2006/metadata/properties/metaAttributes"/>
+    <ds:schemaRef ds:uri="http://www.w3.org/2001/XMLSchema"/>
+    <ds:schemaRef ds:uri="http://schemas.microsoft.com/office/2006/metadata/properties"/>
+    <ds:schemaRef ds:uri="http://schemas.openxmlformats.org/package/2006/metadata/core-properties"/>
+    <ds:schemaRef ds:uri="http://purl.org/dc/elements/1.1/"/>
+    <ds:schemaRef ds:uri="http://purl.org/dc/terms/"/>
+    <ds:schemaRef ds:uri="http://schemas.microsoft.com/internal/obd"/>
+    <ds:schemaRef ds:uri="http://schemas.microsoft.com/office/infopath/2007/PartnerControls"/>
+  </ds:schemaRefs>
+</ds:datastoreItem>
+</file>
+
+<file path=customXml/itemProps2.xml><?xml version="1.0" encoding="utf-8"?>
 <ds:datastoreItem xmlns:ds="http://schemas.openxmlformats.org/officeDocument/2006/customXml" ds:itemID="{48902E4C-83E2-4C18-8096-33894AA2AFBF}">
   <ds:schemaRefs>
     <ds:schemaRef ds:uri="http://www.w3.org/XML/1998/namespace"/>
@@ -37155,26 +38802,10 @@
 </ds:datastoreItem>
 </file>
 
-<file path=customXml/itemProps2.xml><?xml version="1.0" encoding="utf-8"?>
+<file path=customXml/itemProps3.xml><?xml version="1.0" encoding="utf-8"?>
 <ds:datastoreItem xmlns:ds="http://schemas.openxmlformats.org/officeDocument/2006/customXml" ds:itemID="{7665101C-B8E5-42F2-887B-AFFA0513CF0E}">
   <ds:schemaRefs>
     <ds:schemaRef ds:uri="http://schemas.microsoft.com/sharepoint/v3/contenttype/forms"/>
   </ds:schemaRefs>
 </ds:datastoreItem>
-</file>
-
-<file path=customXml/itemProps3.xml><?xml version="1.0" encoding="utf-8"?>
-<ds:datastoreItem xmlns:ds="http://schemas.openxmlformats.org/officeDocument/2006/customXml" ds:itemID="{7A5F66AF-335A-4B7B-A5ED-C6A0F99985B0}">
-  <ds:schemaRefs>
-    <ds:schemaRef ds:uri="http://schemas.microsoft.com/office/2006/metadata/contentType"/>
-    <ds:schemaRef ds:uri="http://schemas.microsoft.com/office/2006/metadata/properties/metaAttributes"/>
-    <ds:schemaRef ds:uri="http://www.w3.org/2001/XMLSchema"/>
-    <ds:schemaRef ds:uri="http://schemas.microsoft.com/office/2006/metadata/properties"/>
-    <ds:schemaRef ds:uri="http://schemas.openxmlformats.org/package/2006/metadata/core-properties"/>
-    <ds:schemaRef ds:uri="http://purl.org/dc/elements/1.1/"/>
-    <ds:schemaRef ds:uri="http://purl.org/dc/terms/"/>
-    <ds:schemaRef ds:uri="http://schemas.microsoft.com/internal/obd"/>
-    <ds:schemaRef ds:uri="http://schemas.microsoft.com/office/infopath/2007/PartnerControls"/>
-  </ds:schemaRefs>
-</ds:datastoreItem>
 </file>
</xml_diff>

<commit_message>
Script detection: faint OCR readings count as evidence (test accuracy 79.2% -> 86.3%)
</commit_message>
<xml_diff>
--- a/docs/RailScan_overview.pptx
+++ b/docs/RailScan_overview.pptx
@@ -33620,7 +33620,7 @@
                   <a:srgbClr val="5A8A0C"/>
                 </a:solidFill>
               </a:rPr>
-              <a:t>79%</a:t>
+              <a:t>86%</a:t>
             </a:r>
             <a:r>
               <a:rPr lang="en-US" sz="1350" dirty="0">
@@ -33652,7 +33652,7 @@
                   <a:srgbClr val="5A8A0C"/>
                 </a:solidFill>
               </a:rPr>
-              <a:t>72%</a:t>
+              <a:t>80%</a:t>
             </a:r>
             <a:r>
               <a:rPr lang="en-US" sz="1350" dirty="0">
@@ -33668,7 +33668,7 @@
                   <a:srgbClr val="5A8A0C"/>
                 </a:solidFill>
               </a:rPr>
-              <a:t>93%</a:t>
+              <a:t>94%</a:t>
             </a:r>
             <a:r>
               <a:rPr lang="en-US" sz="1350" dirty="0">

</xml_diff>